<commit_message>
fix(kernel): apply shrink-to-fit autofit to board-grade pptx prose
- Add fit:'shrink' + wrap to the variable-length prose boxes (takeaway, footer
  fact cells, lede, bullet cards) so kernel-driven text never overruns the slide
  box; PowerPoint shrinks to fit (native normAutofit).
- Add pptx-autofit-gate test: rendered deck is a valid OOXML package with
  shrink-to-fit autofit on every content slide (guards against regressing the
  text-overrun).
- Regenerate the reference apex-costed-business-case-pack.sample.pptx with the fix.
</commit_message>
<xml_diff>
--- a/apex-costed-business-case-pack.sample.pptx
+++ b/apex-costed-business-case-pack.sample.pptx
@@ -2354,7 +2354,7 @@
                 <a:ea typeface="Arial" pitchFamily="34" charset="-122"/>
                 <a:cs typeface="Arial" pitchFamily="34" charset="-120"/>
               </a:rPr>
-              <a:t>2026-05-20</a:t>
+              <a:t>2026-06-06</a:t>
             </a:r>
             <a:endParaRPr lang="en-US" sz="850" dirty="0"/>
           </a:p>
@@ -2578,7 +2578,9 @@
           <a:ln/>
         </p:spPr>
         <p:txBody>
-          <a:bodyPr wrap="square" rtlCol="0" anchor="t"/>
+          <a:bodyPr wrap="square" rtlCol="0" anchor="t">
+            <a:normAutofit/>
+          </a:bodyPr>
           <a:lstStyle/>
           <a:p>
             <a:pPr algn="l" indent="0" marL="0">
@@ -2620,7 +2622,9 @@
           <a:ln/>
         </p:spPr>
         <p:txBody>
-          <a:bodyPr wrap="square" rtlCol="0" anchor="t"/>
+          <a:bodyPr wrap="square" rtlCol="0" anchor="t">
+            <a:normAutofit/>
+          </a:bodyPr>
           <a:lstStyle/>
           <a:p>
             <a:pPr algn="l" indent="0" marL="0">
@@ -5628,7 +5632,9 @@
           <a:ln/>
         </p:spPr>
         <p:txBody>
-          <a:bodyPr wrap="square" rtlCol="0" anchor="t"/>
+          <a:bodyPr wrap="square" rtlCol="0" anchor="t">
+            <a:normAutofit/>
+          </a:bodyPr>
           <a:lstStyle/>
           <a:p>
             <a:pPr algn="l" indent="0" marL="0">
@@ -5690,7 +5696,9 @@
           <a:ln/>
         </p:spPr>
         <p:txBody>
-          <a:bodyPr wrap="square" rtlCol="0" anchor="t"/>
+          <a:bodyPr wrap="square" rtlCol="0" anchor="t">
+            <a:normAutofit/>
+          </a:bodyPr>
           <a:lstStyle/>
           <a:p>
             <a:pPr algn="l" indent="0" marL="0">
@@ -5752,7 +5760,9 @@
           <a:ln/>
         </p:spPr>
         <p:txBody>
-          <a:bodyPr wrap="square" rtlCol="0" anchor="t"/>
+          <a:bodyPr wrap="square" rtlCol="0" anchor="t">
+            <a:normAutofit/>
+          </a:bodyPr>
           <a:lstStyle/>
           <a:p>
             <a:pPr algn="l" indent="0" marL="0">
@@ -5790,7 +5800,7 @@
                 <a:ea typeface="Arial" pitchFamily="34" charset="-122"/>
                 <a:cs typeface="Arial" pitchFamily="34" charset="-120"/>
               </a:rPr>
-              <a:t>1 source · as of 2026-05-20 · confidence Low · 2 open gaps</a:t>
+              <a:t>1 source · as of 2026-06-06 · confidence Low · 2 open gaps</a:t>
             </a:r>
             <a:endParaRPr lang="en-US" sz="700" dirty="0"/>
           </a:p>
@@ -5814,7 +5824,9 @@
           <a:ln/>
         </p:spPr>
         <p:txBody>
-          <a:bodyPr wrap="square" rtlCol="0" anchor="t"/>
+          <a:bodyPr wrap="square" rtlCol="0" anchor="t">
+            <a:normAutofit/>
+          </a:bodyPr>
           <a:lstStyle/>
           <a:p>
             <a:pPr algn="l" indent="0" marL="0">
@@ -6076,7 +6088,9 @@
           <a:ln/>
         </p:spPr>
         <p:txBody>
-          <a:bodyPr wrap="square" rtlCol="0" anchor="t"/>
+          <a:bodyPr wrap="square" rtlCol="0" anchor="t">
+            <a:normAutofit/>
+          </a:bodyPr>
           <a:lstStyle/>
           <a:p>
             <a:pPr algn="l" indent="0" marL="0">
@@ -6118,7 +6132,9 @@
           <a:ln/>
         </p:spPr>
         <p:txBody>
-          <a:bodyPr wrap="square" rtlCol="0" anchor="t"/>
+          <a:bodyPr wrap="square" rtlCol="0" anchor="t">
+            <a:normAutofit/>
+          </a:bodyPr>
           <a:lstStyle/>
           <a:p>
             <a:pPr algn="l" indent="0" marL="0">
@@ -10090,7 +10106,9 @@
           <a:ln/>
         </p:spPr>
         <p:txBody>
-          <a:bodyPr wrap="square" rtlCol="0" anchor="t"/>
+          <a:bodyPr wrap="square" rtlCol="0" anchor="t">
+            <a:normAutofit/>
+          </a:bodyPr>
           <a:lstStyle/>
           <a:p>
             <a:pPr algn="l" indent="0" marL="0">
@@ -10152,7 +10170,9 @@
           <a:ln/>
         </p:spPr>
         <p:txBody>
-          <a:bodyPr wrap="square" rtlCol="0" anchor="t"/>
+          <a:bodyPr wrap="square" rtlCol="0" anchor="t">
+            <a:normAutofit/>
+          </a:bodyPr>
           <a:lstStyle/>
           <a:p>
             <a:pPr algn="l" indent="0" marL="0">
@@ -10214,7 +10234,9 @@
           <a:ln/>
         </p:spPr>
         <p:txBody>
-          <a:bodyPr wrap="square" rtlCol="0" anchor="t"/>
+          <a:bodyPr wrap="square" rtlCol="0" anchor="t">
+            <a:normAutofit/>
+          </a:bodyPr>
           <a:lstStyle/>
           <a:p>
             <a:pPr algn="l" indent="0" marL="0">
@@ -10276,7 +10298,9 @@
           <a:ln/>
         </p:spPr>
         <p:txBody>
-          <a:bodyPr wrap="square" rtlCol="0" anchor="t"/>
+          <a:bodyPr wrap="square" rtlCol="0" anchor="t">
+            <a:normAutofit/>
+          </a:bodyPr>
           <a:lstStyle/>
           <a:p>
             <a:pPr algn="l" indent="0" marL="0">
@@ -10538,7 +10562,9 @@
           <a:ln/>
         </p:spPr>
         <p:txBody>
-          <a:bodyPr wrap="square" rtlCol="0" anchor="t"/>
+          <a:bodyPr wrap="square" rtlCol="0" anchor="t">
+            <a:normAutofit/>
+          </a:bodyPr>
           <a:lstStyle/>
           <a:p>
             <a:pPr algn="l" indent="0" marL="0">
@@ -12077,7 +12103,9 @@
           <a:ln/>
         </p:spPr>
         <p:txBody>
-          <a:bodyPr wrap="square" rtlCol="0" anchor="t"/>
+          <a:bodyPr wrap="square" rtlCol="0" anchor="t">
+            <a:normAutofit/>
+          </a:bodyPr>
           <a:lstStyle/>
           <a:p>
             <a:pPr algn="l" indent="0" marL="0">
@@ -12139,7 +12167,9 @@
           <a:ln/>
         </p:spPr>
         <p:txBody>
-          <a:bodyPr wrap="square" rtlCol="0" anchor="t"/>
+          <a:bodyPr wrap="square" rtlCol="0" anchor="t">
+            <a:normAutofit/>
+          </a:bodyPr>
           <a:lstStyle/>
           <a:p>
             <a:pPr algn="l" indent="0" marL="0">
@@ -12201,7 +12231,9 @@
           <a:ln/>
         </p:spPr>
         <p:txBody>
-          <a:bodyPr wrap="square" rtlCol="0" anchor="t"/>
+          <a:bodyPr wrap="square" rtlCol="0" anchor="t">
+            <a:normAutofit/>
+          </a:bodyPr>
           <a:lstStyle/>
           <a:p>
             <a:pPr algn="l" indent="0" marL="0">
@@ -12239,7 +12271,7 @@
                 <a:ea typeface="Arial" pitchFamily="34" charset="-122"/>
                 <a:cs typeface="Arial" pitchFamily="34" charset="-120"/>
               </a:rPr>
-              <a:t>2 sources · as of 2026-05-20 · confidence Blocked · 4 open gaps</a:t>
+              <a:t>2 sources · as of 2026-06-06 · confidence Blocked · 4 open gaps</a:t>
             </a:r>
             <a:endParaRPr lang="en-US" sz="700" dirty="0"/>
           </a:p>
@@ -12263,7 +12295,9 @@
           <a:ln/>
         </p:spPr>
         <p:txBody>
-          <a:bodyPr wrap="square" rtlCol="0" anchor="t"/>
+          <a:bodyPr wrap="square" rtlCol="0" anchor="t">
+            <a:normAutofit/>
+          </a:bodyPr>
           <a:lstStyle/>
           <a:p>
             <a:pPr algn="l" indent="0" marL="0">
@@ -12525,7 +12559,9 @@
           <a:ln/>
         </p:spPr>
         <p:txBody>
-          <a:bodyPr wrap="square" rtlCol="0" anchor="t"/>
+          <a:bodyPr wrap="square" rtlCol="0" anchor="t">
+            <a:normAutofit/>
+          </a:bodyPr>
           <a:lstStyle/>
           <a:p>
             <a:pPr algn="l" indent="0" marL="0">
@@ -13439,7 +13475,9 @@
           <a:ln/>
         </p:spPr>
         <p:txBody>
-          <a:bodyPr wrap="square" rtlCol="0" anchor="t"/>
+          <a:bodyPr wrap="square" rtlCol="0" anchor="t">
+            <a:normAutofit/>
+          </a:bodyPr>
           <a:lstStyle/>
           <a:p>
             <a:pPr algn="l" marL="152400" indent="-152400">
@@ -13622,7 +13660,9 @@
           <a:ln/>
         </p:spPr>
         <p:txBody>
-          <a:bodyPr wrap="square" rtlCol="0" anchor="t"/>
+          <a:bodyPr wrap="square" rtlCol="0" anchor="t">
+            <a:normAutofit/>
+          </a:bodyPr>
           <a:lstStyle/>
           <a:p>
             <a:pPr algn="l" marL="152400" indent="-152400">
@@ -13739,7 +13779,9 @@
           <a:ln/>
         </p:spPr>
         <p:txBody>
-          <a:bodyPr wrap="square" rtlCol="0" anchor="t"/>
+          <a:bodyPr wrap="square" rtlCol="0" anchor="t">
+            <a:normAutofit/>
+          </a:bodyPr>
           <a:lstStyle/>
           <a:p>
             <a:pPr algn="l" indent="0" marL="0">
@@ -13801,7 +13843,9 @@
           <a:ln/>
         </p:spPr>
         <p:txBody>
-          <a:bodyPr wrap="square" rtlCol="0" anchor="t"/>
+          <a:bodyPr wrap="square" rtlCol="0" anchor="t">
+            <a:normAutofit/>
+          </a:bodyPr>
           <a:lstStyle/>
           <a:p>
             <a:pPr algn="l" indent="0" marL="0">
@@ -13863,7 +13907,9 @@
           <a:ln/>
         </p:spPr>
         <p:txBody>
-          <a:bodyPr wrap="square" rtlCol="0" anchor="t"/>
+          <a:bodyPr wrap="square" rtlCol="0" anchor="t">
+            <a:normAutofit/>
+          </a:bodyPr>
           <a:lstStyle/>
           <a:p>
             <a:pPr algn="l" indent="0" marL="0">
@@ -13901,7 +13947,7 @@
                 <a:ea typeface="Arial" pitchFamily="34" charset="-122"/>
                 <a:cs typeface="Arial" pitchFamily="34" charset="-120"/>
               </a:rPr>
-              <a:t>2 sources · as of 2026-05-20 · confidence Blocked · 4 open gaps</a:t>
+              <a:t>2 sources · as of 2026-06-06 · confidence Blocked · 4 open gaps</a:t>
             </a:r>
             <a:endParaRPr lang="en-US" sz="700" dirty="0"/>
           </a:p>
@@ -13925,7 +13971,9 @@
           <a:ln/>
         </p:spPr>
         <p:txBody>
-          <a:bodyPr wrap="square" rtlCol="0" anchor="t"/>
+          <a:bodyPr wrap="square" rtlCol="0" anchor="t">
+            <a:normAutofit/>
+          </a:bodyPr>
           <a:lstStyle/>
           <a:p>
             <a:pPr algn="l" indent="0" marL="0">
@@ -14187,7 +14235,9 @@
           <a:ln/>
         </p:spPr>
         <p:txBody>
-          <a:bodyPr wrap="square" rtlCol="0" anchor="t"/>
+          <a:bodyPr wrap="square" rtlCol="0" anchor="t">
+            <a:normAutofit/>
+          </a:bodyPr>
           <a:lstStyle/>
           <a:p>
             <a:pPr algn="l" indent="0" marL="0">
@@ -14229,7 +14279,9 @@
           <a:ln/>
         </p:spPr>
         <p:txBody>
-          <a:bodyPr wrap="square" rtlCol="0" anchor="t"/>
+          <a:bodyPr wrap="square" rtlCol="0" anchor="t">
+            <a:normAutofit/>
+          </a:bodyPr>
           <a:lstStyle/>
           <a:p>
             <a:pPr algn="l" indent="0" marL="0">
@@ -14382,7 +14434,9 @@
           <a:ln/>
         </p:spPr>
         <p:txBody>
-          <a:bodyPr wrap="square" rtlCol="0" anchor="t"/>
+          <a:bodyPr wrap="square" rtlCol="0" anchor="t">
+            <a:normAutofit/>
+          </a:bodyPr>
           <a:lstStyle/>
           <a:p>
             <a:pPr algn="l" indent="0" marL="0">
@@ -14444,7 +14498,9 @@
           <a:ln/>
         </p:spPr>
         <p:txBody>
-          <a:bodyPr wrap="square" rtlCol="0" anchor="t"/>
+          <a:bodyPr wrap="square" rtlCol="0" anchor="t">
+            <a:normAutofit/>
+          </a:bodyPr>
           <a:lstStyle/>
           <a:p>
             <a:pPr algn="l" indent="0" marL="0">
@@ -14506,7 +14562,9 @@
           <a:ln/>
         </p:spPr>
         <p:txBody>
-          <a:bodyPr wrap="square" rtlCol="0" anchor="t"/>
+          <a:bodyPr wrap="square" rtlCol="0" anchor="t">
+            <a:normAutofit/>
+          </a:bodyPr>
           <a:lstStyle/>
           <a:p>
             <a:pPr algn="l" indent="0" marL="0">
@@ -14568,7 +14626,9 @@
           <a:ln/>
         </p:spPr>
         <p:txBody>
-          <a:bodyPr wrap="square" rtlCol="0" anchor="t"/>
+          <a:bodyPr wrap="square" rtlCol="0" anchor="t">
+            <a:normAutofit/>
+          </a:bodyPr>
           <a:lstStyle/>
           <a:p>
             <a:pPr algn="l" indent="0" marL="0">
@@ -14830,7 +14890,9 @@
           <a:ln/>
         </p:spPr>
         <p:txBody>
-          <a:bodyPr wrap="square" rtlCol="0" anchor="t"/>
+          <a:bodyPr wrap="square" rtlCol="0" anchor="t">
+            <a:normAutofit/>
+          </a:bodyPr>
           <a:lstStyle/>
           <a:p>
             <a:pPr algn="l" indent="0" marL="0">
@@ -14872,7 +14934,9 @@
           <a:ln/>
         </p:spPr>
         <p:txBody>
-          <a:bodyPr wrap="square" rtlCol="0" anchor="t"/>
+          <a:bodyPr wrap="square" rtlCol="0" anchor="t">
+            <a:normAutofit/>
+          </a:bodyPr>
           <a:lstStyle/>
           <a:p>
             <a:pPr algn="l" indent="0" marL="0">
@@ -15003,7 +15067,9 @@
           <a:ln/>
         </p:spPr>
         <p:txBody>
-          <a:bodyPr wrap="square" rtlCol="0" anchor="t"/>
+          <a:bodyPr wrap="square" rtlCol="0" anchor="t">
+            <a:normAutofit/>
+          </a:bodyPr>
           <a:lstStyle/>
           <a:p>
             <a:pPr algn="l" marL="152400" indent="-152400">
@@ -15234,7 +15300,9 @@
           <a:ln/>
         </p:spPr>
         <p:txBody>
-          <a:bodyPr wrap="square" rtlCol="0" anchor="t"/>
+          <a:bodyPr wrap="square" rtlCol="0" anchor="t">
+            <a:normAutofit/>
+          </a:bodyPr>
           <a:lstStyle/>
           <a:p>
             <a:pPr algn="l" marL="152400" indent="-152400">
@@ -15417,7 +15485,9 @@
           <a:ln/>
         </p:spPr>
         <p:txBody>
-          <a:bodyPr wrap="square" rtlCol="0" anchor="t"/>
+          <a:bodyPr wrap="square" rtlCol="0" anchor="t">
+            <a:normAutofit/>
+          </a:bodyPr>
           <a:lstStyle/>
           <a:p>
             <a:pPr algn="l" marL="152400" indent="-152400">
@@ -15534,7 +15604,9 @@
           <a:ln/>
         </p:spPr>
         <p:txBody>
-          <a:bodyPr wrap="square" rtlCol="0" anchor="t"/>
+          <a:bodyPr wrap="square" rtlCol="0" anchor="t">
+            <a:normAutofit/>
+          </a:bodyPr>
           <a:lstStyle/>
           <a:p>
             <a:pPr algn="l" indent="0" marL="0">
@@ -15596,7 +15668,9 @@
           <a:ln/>
         </p:spPr>
         <p:txBody>
-          <a:bodyPr wrap="square" rtlCol="0" anchor="t"/>
+          <a:bodyPr wrap="square" rtlCol="0" anchor="t">
+            <a:normAutofit/>
+          </a:bodyPr>
           <a:lstStyle/>
           <a:p>
             <a:pPr algn="l" indent="0" marL="0">
@@ -15658,7 +15732,9 @@
           <a:ln/>
         </p:spPr>
         <p:txBody>
-          <a:bodyPr wrap="square" rtlCol="0" anchor="t"/>
+          <a:bodyPr wrap="square" rtlCol="0" anchor="t">
+            <a:normAutofit/>
+          </a:bodyPr>
           <a:lstStyle/>
           <a:p>
             <a:pPr algn="l" indent="0" marL="0">
@@ -15696,7 +15772,7 @@
                 <a:ea typeface="Arial" pitchFamily="34" charset="-122"/>
                 <a:cs typeface="Arial" pitchFamily="34" charset="-120"/>
               </a:rPr>
-              <a:t>3 sources · as of 2026-05-20 · confidence Medium · 1 open gap</a:t>
+              <a:t>3 sources · as of 2026-06-06 · confidence Medium · 1 open gap</a:t>
             </a:r>
             <a:endParaRPr lang="en-US" sz="700" dirty="0"/>
           </a:p>
@@ -15720,7 +15796,9 @@
           <a:ln/>
         </p:spPr>
         <p:txBody>
-          <a:bodyPr wrap="square" rtlCol="0" anchor="t"/>
+          <a:bodyPr wrap="square" rtlCol="0" anchor="t">
+            <a:normAutofit/>
+          </a:bodyPr>
           <a:lstStyle/>
           <a:p>
             <a:pPr algn="l" indent="0" marL="0">
@@ -15982,7 +16060,9 @@
           <a:ln/>
         </p:spPr>
         <p:txBody>
-          <a:bodyPr wrap="square" rtlCol="0" anchor="t"/>
+          <a:bodyPr wrap="square" rtlCol="0" anchor="t">
+            <a:normAutofit/>
+          </a:bodyPr>
           <a:lstStyle/>
           <a:p>
             <a:pPr algn="l" indent="0" marL="0">
@@ -16024,7 +16104,9 @@
           <a:ln/>
         </p:spPr>
         <p:txBody>
-          <a:bodyPr wrap="square" rtlCol="0" anchor="t"/>
+          <a:bodyPr wrap="square" rtlCol="0" anchor="t">
+            <a:normAutofit/>
+          </a:bodyPr>
           <a:lstStyle/>
           <a:p>
             <a:pPr algn="l" indent="0" marL="0">
@@ -19008,7 +19090,9 @@
           <a:ln/>
         </p:spPr>
         <p:txBody>
-          <a:bodyPr wrap="square" rtlCol="0" anchor="t"/>
+          <a:bodyPr wrap="square" rtlCol="0" anchor="t">
+            <a:normAutofit/>
+          </a:bodyPr>
           <a:lstStyle/>
           <a:p>
             <a:pPr algn="l" indent="0" marL="0">
@@ -19070,7 +19154,9 @@
           <a:ln/>
         </p:spPr>
         <p:txBody>
-          <a:bodyPr wrap="square" rtlCol="0" anchor="t"/>
+          <a:bodyPr wrap="square" rtlCol="0" anchor="t">
+            <a:normAutofit/>
+          </a:bodyPr>
           <a:lstStyle/>
           <a:p>
             <a:pPr algn="l" indent="0" marL="0">
@@ -19132,7 +19218,9 @@
           <a:ln/>
         </p:spPr>
         <p:txBody>
-          <a:bodyPr wrap="square" rtlCol="0" anchor="t"/>
+          <a:bodyPr wrap="square" rtlCol="0" anchor="t">
+            <a:normAutofit/>
+          </a:bodyPr>
           <a:lstStyle/>
           <a:p>
             <a:pPr algn="l" indent="0" marL="0">
@@ -19170,7 +19258,7 @@
                 <a:ea typeface="Arial" pitchFamily="34" charset="-122"/>
                 <a:cs typeface="Arial" pitchFamily="34" charset="-120"/>
               </a:rPr>
-              <a:t>2 sources · as of 2026-05-20 · confidence Medium · 1 open gap</a:t>
+              <a:t>2 sources · as of 2026-06-06 · confidence Medium · 1 open gap</a:t>
             </a:r>
             <a:endParaRPr lang="en-US" sz="700" dirty="0"/>
           </a:p>
@@ -19194,7 +19282,9 @@
           <a:ln/>
         </p:spPr>
         <p:txBody>
-          <a:bodyPr wrap="square" rtlCol="0" anchor="t"/>
+          <a:bodyPr wrap="square" rtlCol="0" anchor="t">
+            <a:normAutofit/>
+          </a:bodyPr>
           <a:lstStyle/>
           <a:p>
             <a:pPr algn="l" indent="0" marL="0">
@@ -19456,7 +19546,9 @@
           <a:ln/>
         </p:spPr>
         <p:txBody>
-          <a:bodyPr wrap="square" rtlCol="0" anchor="t"/>
+          <a:bodyPr wrap="square" rtlCol="0" anchor="t">
+            <a:normAutofit/>
+          </a:bodyPr>
           <a:lstStyle/>
           <a:p>
             <a:pPr algn="l" indent="0" marL="0">
@@ -19498,7 +19590,9 @@
           <a:ln/>
         </p:spPr>
         <p:txBody>
-          <a:bodyPr wrap="square" rtlCol="0" anchor="t"/>
+          <a:bodyPr wrap="square" rtlCol="0" anchor="t">
+            <a:normAutofit/>
+          </a:bodyPr>
           <a:lstStyle/>
           <a:p>
             <a:pPr algn="l" indent="0" marL="0">
@@ -21640,7 +21734,9 @@
           <a:ln/>
         </p:spPr>
         <p:txBody>
-          <a:bodyPr wrap="square" rtlCol="0" anchor="t"/>
+          <a:bodyPr wrap="square" rtlCol="0" anchor="t">
+            <a:normAutofit/>
+          </a:bodyPr>
           <a:lstStyle/>
           <a:p>
             <a:pPr algn="l" indent="0" marL="0">
@@ -21702,7 +21798,9 @@
           <a:ln/>
         </p:spPr>
         <p:txBody>
-          <a:bodyPr wrap="square" rtlCol="0" anchor="t"/>
+          <a:bodyPr wrap="square" rtlCol="0" anchor="t">
+            <a:normAutofit/>
+          </a:bodyPr>
           <a:lstStyle/>
           <a:p>
             <a:pPr algn="l" indent="0" marL="0">
@@ -21764,7 +21862,9 @@
           <a:ln/>
         </p:spPr>
         <p:txBody>
-          <a:bodyPr wrap="square" rtlCol="0" anchor="t"/>
+          <a:bodyPr wrap="square" rtlCol="0" anchor="t">
+            <a:normAutofit/>
+          </a:bodyPr>
           <a:lstStyle/>
           <a:p>
             <a:pPr algn="l" indent="0" marL="0">
@@ -21802,7 +21902,7 @@
                 <a:ea typeface="Arial" pitchFamily="34" charset="-122"/>
                 <a:cs typeface="Arial" pitchFamily="34" charset="-120"/>
               </a:rPr>
-              <a:t>2 sources · as of 2026-05-20 · confidence Low · 1 open gap</a:t>
+              <a:t>2 sources · as of 2026-06-06 · confidence Low · 1 open gap</a:t>
             </a:r>
             <a:endParaRPr lang="en-US" sz="700" dirty="0"/>
           </a:p>
@@ -21826,7 +21926,9 @@
           <a:ln/>
         </p:spPr>
         <p:txBody>
-          <a:bodyPr wrap="square" rtlCol="0" anchor="t"/>
+          <a:bodyPr wrap="square" rtlCol="0" anchor="t">
+            <a:normAutofit/>
+          </a:bodyPr>
           <a:lstStyle/>
           <a:p>
             <a:pPr algn="l" indent="0" marL="0">
@@ -22088,7 +22190,9 @@
           <a:ln/>
         </p:spPr>
         <p:txBody>
-          <a:bodyPr wrap="square" rtlCol="0" anchor="t"/>
+          <a:bodyPr wrap="square" rtlCol="0" anchor="t">
+            <a:normAutofit/>
+          </a:bodyPr>
           <a:lstStyle/>
           <a:p>
             <a:pPr algn="l" indent="0" marL="0">
@@ -23554,7 +23658,9 @@
           <a:ln/>
         </p:spPr>
         <p:txBody>
-          <a:bodyPr wrap="square" rtlCol="0" anchor="t"/>
+          <a:bodyPr wrap="square" rtlCol="0" anchor="t">
+            <a:normAutofit/>
+          </a:bodyPr>
           <a:lstStyle/>
           <a:p>
             <a:pPr algn="l" indent="0" marL="0">
@@ -23616,7 +23722,9 @@
           <a:ln/>
         </p:spPr>
         <p:txBody>
-          <a:bodyPr wrap="square" rtlCol="0" anchor="t"/>
+          <a:bodyPr wrap="square" rtlCol="0" anchor="t">
+            <a:normAutofit/>
+          </a:bodyPr>
           <a:lstStyle/>
           <a:p>
             <a:pPr algn="l" indent="0" marL="0">
@@ -23678,7 +23786,9 @@
           <a:ln/>
         </p:spPr>
         <p:txBody>
-          <a:bodyPr wrap="square" rtlCol="0" anchor="t"/>
+          <a:bodyPr wrap="square" rtlCol="0" anchor="t">
+            <a:normAutofit/>
+          </a:bodyPr>
           <a:lstStyle/>
           <a:p>
             <a:pPr algn="l" indent="0" marL="0">
@@ -23716,7 +23826,7 @@
                 <a:ea typeface="Arial" pitchFamily="34" charset="-122"/>
                 <a:cs typeface="Arial" pitchFamily="34" charset="-120"/>
               </a:rPr>
-              <a:t>2 sources · as of 2026-05-20 · confidence Blocked · 1 open gap</a:t>
+              <a:t>2 sources · as of 2026-06-06 · confidence Blocked · 1 open gap</a:t>
             </a:r>
             <a:endParaRPr lang="en-US" sz="700" dirty="0"/>
           </a:p>
@@ -23740,7 +23850,9 @@
           <a:ln/>
         </p:spPr>
         <p:txBody>
-          <a:bodyPr wrap="square" rtlCol="0" anchor="t"/>
+          <a:bodyPr wrap="square" rtlCol="0" anchor="t">
+            <a:normAutofit/>
+          </a:bodyPr>
           <a:lstStyle/>
           <a:p>
             <a:pPr algn="l" indent="0" marL="0">
@@ -24002,7 +24114,9 @@
           <a:ln/>
         </p:spPr>
         <p:txBody>
-          <a:bodyPr wrap="square" rtlCol="0" anchor="t"/>
+          <a:bodyPr wrap="square" rtlCol="0" anchor="t">
+            <a:normAutofit/>
+          </a:bodyPr>
           <a:lstStyle/>
           <a:p>
             <a:pPr algn="l" indent="0" marL="0">
@@ -24044,7 +24158,9 @@
           <a:ln/>
         </p:spPr>
         <p:txBody>
-          <a:bodyPr wrap="square" rtlCol="0" anchor="t"/>
+          <a:bodyPr wrap="square" rtlCol="0" anchor="t">
+            <a:normAutofit/>
+          </a:bodyPr>
           <a:lstStyle/>
           <a:p>
             <a:pPr algn="l" indent="0" marL="0">
@@ -25638,7 +25754,9 @@
           <a:ln/>
         </p:spPr>
         <p:txBody>
-          <a:bodyPr wrap="square" rtlCol="0" anchor="t"/>
+          <a:bodyPr wrap="square" rtlCol="0" anchor="t">
+            <a:normAutofit/>
+          </a:bodyPr>
           <a:lstStyle/>
           <a:p>
             <a:pPr algn="l" indent="0" marL="0">
@@ -25700,7 +25818,9 @@
           <a:ln/>
         </p:spPr>
         <p:txBody>
-          <a:bodyPr wrap="square" rtlCol="0" anchor="t"/>
+          <a:bodyPr wrap="square" rtlCol="0" anchor="t">
+            <a:normAutofit/>
+          </a:bodyPr>
           <a:lstStyle/>
           <a:p>
             <a:pPr algn="l" indent="0" marL="0">
@@ -25762,7 +25882,9 @@
           <a:ln/>
         </p:spPr>
         <p:txBody>
-          <a:bodyPr wrap="square" rtlCol="0" anchor="t"/>
+          <a:bodyPr wrap="square" rtlCol="0" anchor="t">
+            <a:normAutofit/>
+          </a:bodyPr>
           <a:lstStyle/>
           <a:p>
             <a:pPr algn="l" indent="0" marL="0">
@@ -25800,7 +25922,7 @@
                 <a:ea typeface="Arial" pitchFamily="34" charset="-122"/>
                 <a:cs typeface="Arial" pitchFamily="34" charset="-120"/>
               </a:rPr>
-              <a:t>2 sources · as of 2026-05-20 · confidence Medium · No open gaps</a:t>
+              <a:t>2 sources · as of 2026-06-06 · confidence Medium · No open gaps</a:t>
             </a:r>
             <a:endParaRPr lang="en-US" sz="700" dirty="0"/>
           </a:p>
@@ -25824,7 +25946,9 @@
           <a:ln/>
         </p:spPr>
         <p:txBody>
-          <a:bodyPr wrap="square" rtlCol="0" anchor="t"/>
+          <a:bodyPr wrap="square" rtlCol="0" anchor="t">
+            <a:normAutofit/>
+          </a:bodyPr>
           <a:lstStyle/>
           <a:p>
             <a:pPr algn="l" indent="0" marL="0">
@@ -26086,7 +26210,9 @@
           <a:ln/>
         </p:spPr>
         <p:txBody>
-          <a:bodyPr wrap="square" rtlCol="0" anchor="t"/>
+          <a:bodyPr wrap="square" rtlCol="0" anchor="t">
+            <a:normAutofit/>
+          </a:bodyPr>
           <a:lstStyle/>
           <a:p>
             <a:pPr algn="l" indent="0" marL="0">
@@ -26128,7 +26254,9 @@
           <a:ln/>
         </p:spPr>
         <p:txBody>
-          <a:bodyPr wrap="square" rtlCol="0" anchor="t"/>
+          <a:bodyPr wrap="square" rtlCol="0" anchor="t">
+            <a:normAutofit/>
+          </a:bodyPr>
           <a:lstStyle/>
           <a:p>
             <a:pPr algn="l" indent="0" marL="0">
@@ -28747,7 +28875,9 @@
           <a:ln/>
         </p:spPr>
         <p:txBody>
-          <a:bodyPr wrap="square" rtlCol="0" anchor="t"/>
+          <a:bodyPr wrap="square" rtlCol="0" anchor="t">
+            <a:normAutofit/>
+          </a:bodyPr>
           <a:lstStyle/>
           <a:p>
             <a:pPr algn="l" indent="0" marL="0">
@@ -28809,7 +28939,9 @@
           <a:ln/>
         </p:spPr>
         <p:txBody>
-          <a:bodyPr wrap="square" rtlCol="0" anchor="t"/>
+          <a:bodyPr wrap="square" rtlCol="0" anchor="t">
+            <a:normAutofit/>
+          </a:bodyPr>
           <a:lstStyle/>
           <a:p>
             <a:pPr algn="l" indent="0" marL="0">
@@ -28871,7 +29003,9 @@
           <a:ln/>
         </p:spPr>
         <p:txBody>
-          <a:bodyPr wrap="square" rtlCol="0" anchor="t"/>
+          <a:bodyPr wrap="square" rtlCol="0" anchor="t">
+            <a:normAutofit/>
+          </a:bodyPr>
           <a:lstStyle/>
           <a:p>
             <a:pPr algn="l" indent="0" marL="0">
@@ -28909,7 +29043,7 @@
                 <a:ea typeface="Arial" pitchFamily="34" charset="-122"/>
                 <a:cs typeface="Arial" pitchFamily="34" charset="-120"/>
               </a:rPr>
-              <a:t>3 sources · as of 2026-05-20 · confidence Medium · 1 open gap</a:t>
+              <a:t>3 sources · as of 2026-06-06 · confidence Medium · 1 open gap</a:t>
             </a:r>
             <a:endParaRPr lang="en-US" sz="700" dirty="0"/>
           </a:p>
@@ -28933,7 +29067,9 @@
           <a:ln/>
         </p:spPr>
         <p:txBody>
-          <a:bodyPr wrap="square" rtlCol="0" anchor="t"/>
+          <a:bodyPr wrap="square" rtlCol="0" anchor="t">
+            <a:normAutofit/>
+          </a:bodyPr>
           <a:lstStyle/>
           <a:p>
             <a:pPr algn="l" indent="0" marL="0">

</xml_diff>